<commit_message>
Replace all occurrences of suryah with riddhiman across project report and presentation
</commit_message>
<xml_diff>
--- a/BANK MANAGEMENT SYSTEM.pptx
+++ b/BANK MANAGEMENT SYSTEM.pptx
@@ -21425,7 +21425,7 @@
                   <a:cs typeface="Inter ExtraBold"/>
                   <a:sym typeface="Inter ExtraBold"/>
                 </a:rPr>
-                <a:t>S.S. SURYAH</a:t>
+                <a:t>RIDDHIMAN GHOSH</a:t>
               </a:r>
               <a:endParaRPr b="1" i="0" sz="1000">
                 <a:solidFill>
@@ -31532,7 +31532,7 @@
                   <a:cs typeface="Courier New"/>
                   <a:sym typeface="Courier New"/>
                 </a:rPr>
-                <a:t>suryah</a:t>
+                <a:t>riddhiman</a:t>
               </a:r>
               <a:endParaRPr b="0" sz="1000">
                 <a:solidFill>
@@ -32135,7 +32135,7 @@
                   <a:cs typeface="Inter"/>
                   <a:sym typeface="Inter"/>
                 </a:rPr>
-                <a:t>Authenticates credentials for user 'suryah' using PIN verification.</a:t>
+                <a:t>Authenticates credentials for user 'riddhiman' using PIN verification.</a:t>
               </a:r>
               <a:endParaRPr b="0" sz="833">
                 <a:solidFill>

</xml_diff>